<commit_message>
v20261007 Add key-pair auth, gitignore, config example, and README
- Snowflake connection now supports optional private key file auth
- Added .gitignore (excludes config.ini, secret.key, logs, caches)
- Added config.ini.example as a sanitized template
- Updated README.md with full setup and config documentation
- Updated PPTX to document new private_key_file/passphrase prompts

Co-Authored-By: Claude Sonnet 4.6 <noreply@anthropic.com>
</commit_message>
<xml_diff>
--- a/CDGC Snowflake Updater.pptx
+++ b/CDGC Snowflake Updater.pptx
@@ -238,7 +238,7 @@
           <a:p>
             <a:fld id="{A8AF0ABA-1503-4581-BC5A-AF3D56D7DD45}" type="datetimeFigureOut">
               <a:rPr lang="en-US" smtClean="0"/>
-              <a:t>3/20/2026</a:t>
+              <a:t>10/7/2026</a:t>
             </a:fld>
             <a:endParaRPr lang="en-US"/>
           </a:p>
@@ -403,7 +403,7 @@
           <a:p>
             <a:fld id="{78186FDC-CD1E-4E7E-B1CD-1CBCCD519E8C}" type="datetimeFigureOut">
               <a:rPr lang="en-US" smtClean="0"/>
-              <a:t>3/20/2026</a:t>
+              <a:t>10/7/2026</a:t>
             </a:fld>
             <a:endParaRPr lang="en-US"/>
           </a:p>
@@ -22707,6 +22707,23 @@
               <a:buFont typeface="Arial" panose="020B0604020202020204" pitchFamily="34" charset="0"/>
               <a:buChar char="•"/>
             </a:pPr>
+            <a:endParaRPr lang="en-US" sz="2100" dirty="0">
+              <a:latin typeface="Roboto" charset="0"/>
+              <a:ea typeface="Roboto" charset="0"/>
+              <a:cs typeface="Roboto" charset="0"/>
+            </a:endParaRPr>
+          </a:p>
+          <a:p>
+            <a:pPr marL="342900" lvl="1" indent="-342900">
+              <a:lnSpc>
+                <a:spcPct val="90000"/>
+              </a:lnSpc>
+              <a:spcAft>
+                <a:spcPts val="1000"/>
+              </a:spcAft>
+              <a:buFont typeface="Arial" panose="020B0604020202020204" pitchFamily="34" charset="0"/>
+              <a:buChar char="•"/>
+            </a:pPr>
             <a:r>
               <a:rPr lang="en-US" sz="2100" dirty="0">
                 <a:latin typeface="Roboto" charset="0"/>
@@ -23359,7 +23376,7 @@
               </a:spcAft>
             </a:pPr>
             <a:r>
-              <a:rPr sz="850">
+              <a:rPr sz="850" dirty="0">
                 <a:solidFill>
                   <a:srgbClr val="4EC974"/>
                 </a:solidFill>
@@ -23377,7 +23394,7 @@
                 <a:spcPts val="0"/>
               </a:spcAft>
             </a:pPr>
-            <a:endParaRPr sz="850">
+            <a:endParaRPr sz="850" dirty="0">
               <a:solidFill>
                 <a:srgbClr val="4EC974"/>
               </a:solidFill>
@@ -23394,7 +23411,7 @@
               </a:spcAft>
             </a:pPr>
             <a:r>
-              <a:rPr sz="850">
+              <a:rPr sz="850" dirty="0">
                 <a:solidFill>
                   <a:srgbClr val="FFFFFF"/>
                 </a:solidFill>
@@ -23413,7 +23430,7 @@
               </a:spcAft>
             </a:pPr>
             <a:r>
-              <a:rPr sz="850">
+              <a:rPr sz="850" dirty="0">
                 <a:solidFill>
                   <a:srgbClr val="BBBBBB"/>
                 </a:solidFill>
@@ -23431,7 +23448,7 @@
                 <a:spcPts val="0"/>
               </a:spcAft>
             </a:pPr>
-            <a:endParaRPr sz="850">
+            <a:endParaRPr sz="850" dirty="0">
               <a:solidFill>
                 <a:srgbClr val="BBBBBB"/>
               </a:solidFill>
@@ -23448,7 +23465,7 @@
               </a:spcAft>
             </a:pPr>
             <a:r>
-              <a:rPr sz="850">
+              <a:rPr sz="850" dirty="0">
                 <a:solidFill>
                   <a:srgbClr val="FFD700"/>
                 </a:solidFill>
@@ -23467,14 +23484,29 @@
               </a:spcAft>
             </a:pPr>
             <a:r>
-              <a:rPr sz="850">
+              <a:rPr sz="850" dirty="0">
                 <a:solidFill>
                   <a:srgbClr val="9CDCFE"/>
                 </a:solidFill>
                 <a:latin typeface="Courier New"/>
               </a:rPr>
-              <a:t>  username: shayes_compass</a:t>
-            </a:r>
+              <a:t>  username: </a:t>
+            </a:r>
+            <a:r>
+              <a:rPr sz="850" dirty="0" err="1">
+                <a:solidFill>
+                  <a:srgbClr val="9CDCFE"/>
+                </a:solidFill>
+                <a:latin typeface="Courier New"/>
+              </a:rPr>
+              <a:t>shayes_compass</a:t>
+            </a:r>
+            <a:endParaRPr sz="850" dirty="0">
+              <a:solidFill>
+                <a:srgbClr val="9CDCFE"/>
+              </a:solidFill>
+              <a:latin typeface="Courier New"/>
+            </a:endParaRPr>
           </a:p>
           <a:p>
             <a:pPr>
@@ -23486,7 +23518,7 @@
               </a:spcAft>
             </a:pPr>
             <a:r>
-              <a:rPr sz="850">
+              <a:rPr sz="850" dirty="0">
                 <a:solidFill>
                   <a:srgbClr val="BBBBBB"/>
                 </a:solidFill>
@@ -23505,13 +23537,31 @@
               </a:spcAft>
             </a:pPr>
             <a:r>
-              <a:rPr sz="850">
+              <a:rPr sz="850" dirty="0">
                 <a:solidFill>
                   <a:srgbClr val="9CDCFE"/>
                 </a:solidFill>
                 <a:latin typeface="Courier New"/>
               </a:rPr>
-              <a:t>  encrypted_password: [currently set — encrypted]</a:t>
+              <a:t>  </a:t>
+            </a:r>
+            <a:r>
+              <a:rPr sz="850" dirty="0" err="1">
+                <a:solidFill>
+                  <a:srgbClr val="9CDCFE"/>
+                </a:solidFill>
+                <a:latin typeface="Courier New"/>
+              </a:rPr>
+              <a:t>encrypted_password</a:t>
+            </a:r>
+            <a:r>
+              <a:rPr sz="850" dirty="0">
+                <a:solidFill>
+                  <a:srgbClr val="9CDCFE"/>
+                </a:solidFill>
+                <a:latin typeface="Courier New"/>
+              </a:rPr>
+              <a:t>: [currently set — encrypted]</a:t>
             </a:r>
           </a:p>
           <a:p>
@@ -23524,7 +23574,7 @@
               </a:spcAft>
             </a:pPr>
             <a:r>
-              <a:rPr sz="850">
+              <a:rPr sz="850" dirty="0">
                 <a:solidFill>
                   <a:srgbClr val="FFD700"/>
                 </a:solidFill>
@@ -23543,7 +23593,7 @@
               </a:spcAft>
             </a:pPr>
             <a:r>
-              <a:rPr sz="850">
+              <a:rPr sz="850" dirty="0">
                 <a:solidFill>
                   <a:srgbClr val="BBBBBB"/>
                 </a:solidFill>
@@ -23562,7 +23612,7 @@
               </a:spcAft>
             </a:pPr>
             <a:r>
-              <a:rPr sz="850">
+              <a:rPr sz="850" dirty="0">
                 <a:solidFill>
                   <a:srgbClr val="FFFFFF"/>
                 </a:solidFill>
@@ -23581,13 +23631,31 @@
               </a:spcAft>
             </a:pPr>
             <a:r>
-              <a:rPr sz="850">
+              <a:rPr sz="850" dirty="0">
                 <a:solidFill>
                   <a:srgbClr val="9CDCFE"/>
                 </a:solidFill>
                 <a:latin typeface="Courier New"/>
               </a:rPr>
-              <a:t>  pod: dmp-us</a:t>
+              <a:t>  pod: </a:t>
+            </a:r>
+            <a:r>
+              <a:rPr sz="850" dirty="0" err="1">
+                <a:solidFill>
+                  <a:srgbClr val="9CDCFE"/>
+                </a:solidFill>
+                <a:latin typeface="Courier New"/>
+              </a:rPr>
+              <a:t>dmp</a:t>
+            </a:r>
+            <a:r>
+              <a:rPr sz="850" dirty="0">
+                <a:solidFill>
+                  <a:srgbClr val="9CDCFE"/>
+                </a:solidFill>
+                <a:latin typeface="Courier New"/>
+              </a:rPr>
+              <a:t>-us</a:t>
             </a:r>
           </a:p>
           <a:p>
@@ -23600,7 +23668,7 @@
               </a:spcAft>
             </a:pPr>
             <a:r>
-              <a:rPr sz="850">
+              <a:rPr sz="850" dirty="0">
                 <a:solidFill>
                   <a:srgbClr val="BBBBBB"/>
                 </a:solidFill>
@@ -23619,13 +23687,31 @@
               </a:spcAft>
             </a:pPr>
             <a:r>
-              <a:rPr sz="850">
+              <a:rPr sz="850" dirty="0">
                 <a:solidFill>
                   <a:srgbClr val="9CDCFE"/>
                 </a:solidFill>
                 <a:latin typeface="Courier New"/>
               </a:rPr>
-              <a:t>  catalog_resource_name: NSEN Snowflake Retail Marketing</a:t>
+              <a:t>  </a:t>
+            </a:r>
+            <a:r>
+              <a:rPr sz="850" dirty="0" err="1">
+                <a:solidFill>
+                  <a:srgbClr val="9CDCFE"/>
+                </a:solidFill>
+                <a:latin typeface="Courier New"/>
+              </a:rPr>
+              <a:t>catalog_resource_name</a:t>
+            </a:r>
+            <a:r>
+              <a:rPr sz="850" dirty="0">
+                <a:solidFill>
+                  <a:srgbClr val="9CDCFE"/>
+                </a:solidFill>
+                <a:latin typeface="Courier New"/>
+              </a:rPr>
+              <a:t>: NSEN Snowflake Retail Marketing</a:t>
             </a:r>
           </a:p>
           <a:p>
@@ -23638,7 +23724,7 @@
               </a:spcAft>
             </a:pPr>
             <a:r>
-              <a:rPr sz="850">
+              <a:rPr sz="850" dirty="0">
                 <a:solidFill>
                   <a:srgbClr val="BBBBBB"/>
                 </a:solidFill>
@@ -23656,7 +23742,7 @@
                 <a:spcPts val="0"/>
               </a:spcAft>
             </a:pPr>
-            <a:endParaRPr sz="850">
+            <a:endParaRPr sz="850" dirty="0">
               <a:solidFill>
                 <a:srgbClr val="BBBBBB"/>
               </a:solidFill>
@@ -23673,7 +23759,7 @@
               </a:spcAft>
             </a:pPr>
             <a:r>
-              <a:rPr sz="850">
+              <a:rPr sz="850" dirty="0">
                 <a:solidFill>
                   <a:srgbClr val="FFD700"/>
                 </a:solidFill>
@@ -23692,7 +23778,7 @@
               </a:spcAft>
             </a:pPr>
             <a:r>
-              <a:rPr sz="850">
+              <a:rPr sz="850" dirty="0">
                 <a:solidFill>
                   <a:srgbClr val="9CDCFE"/>
                 </a:solidFill>
@@ -23711,7 +23797,7 @@
               </a:spcAft>
             </a:pPr>
             <a:r>
-              <a:rPr sz="850">
+              <a:rPr sz="850" dirty="0">
                 <a:solidFill>
                   <a:srgbClr val="BBBBBB"/>
                 </a:solidFill>
@@ -23730,7 +23816,7 @@
               </a:spcAft>
             </a:pPr>
             <a:r>
-              <a:rPr sz="850">
+              <a:rPr sz="850" dirty="0">
                 <a:solidFill>
                   <a:srgbClr val="9CDCFE"/>
                 </a:solidFill>
@@ -23749,7 +23835,7 @@
               </a:spcAft>
             </a:pPr>
             <a:r>
-              <a:rPr sz="850">
+              <a:rPr sz="850" dirty="0">
                 <a:solidFill>
                   <a:srgbClr val="BBBBBB"/>
                 </a:solidFill>
@@ -23768,7 +23854,7 @@
               </a:spcAft>
             </a:pPr>
             <a:r>
-              <a:rPr sz="850">
+              <a:rPr sz="850" dirty="0">
                 <a:solidFill>
                   <a:srgbClr val="9CDCFE"/>
                 </a:solidFill>
@@ -23787,7 +23873,7 @@
               </a:spcAft>
             </a:pPr>
             <a:r>
-              <a:rPr sz="850">
+              <a:rPr sz="850" dirty="0">
                 <a:solidFill>
                   <a:srgbClr val="BBBBBB"/>
                 </a:solidFill>
@@ -23806,13 +23892,31 @@
               </a:spcAft>
             </a:pPr>
             <a:r>
-              <a:rPr sz="850">
+              <a:rPr sz="850" dirty="0">
                 <a:solidFill>
                   <a:srgbClr val="9CDCFE"/>
                 </a:solidFill>
                 <a:latin typeface="Courier New"/>
               </a:rPr>
-              <a:t>  encrypted_password: [currently set — encrypted]</a:t>
+              <a:t>  </a:t>
+            </a:r>
+            <a:r>
+              <a:rPr sz="850" dirty="0" err="1">
+                <a:solidFill>
+                  <a:srgbClr val="9CDCFE"/>
+                </a:solidFill>
+                <a:latin typeface="Courier New"/>
+              </a:rPr>
+              <a:t>encrypted_password</a:t>
+            </a:r>
+            <a:r>
+              <a:rPr sz="850" dirty="0">
+                <a:solidFill>
+                  <a:srgbClr val="9CDCFE"/>
+                </a:solidFill>
+                <a:latin typeface="Courier New"/>
+              </a:rPr>
+              <a:t>: [currently set — encrypted]</a:t>
             </a:r>
           </a:p>
           <a:p>
@@ -23825,7 +23929,7 @@
               </a:spcAft>
             </a:pPr>
             <a:r>
-              <a:rPr sz="850">
+              <a:rPr sz="850" dirty="0">
                 <a:solidFill>
                   <a:srgbClr val="FFD700"/>
                 </a:solidFill>
@@ -23844,7 +23948,7 @@
               </a:spcAft>
             </a:pPr>
             <a:r>
-              <a:rPr sz="850">
+              <a:rPr sz="850" dirty="0">
                 <a:solidFill>
                   <a:srgbClr val="BBBBBB"/>
                 </a:solidFill>
@@ -23863,7 +23967,7 @@
               </a:spcAft>
             </a:pPr>
             <a:r>
-              <a:rPr sz="850">
+              <a:rPr sz="850" dirty="0">
                 <a:solidFill>
                   <a:srgbClr val="FFFFFF"/>
                 </a:solidFill>
@@ -23882,7 +23986,7 @@
               </a:spcAft>
             </a:pPr>
             <a:r>
-              <a:rPr sz="850">
+              <a:rPr sz="850" dirty="0">
                 <a:solidFill>
                   <a:srgbClr val="9CDCFE"/>
                 </a:solidFill>
@@ -23901,7 +24005,7 @@
               </a:spcAft>
             </a:pPr>
             <a:r>
-              <a:rPr sz="850">
+              <a:rPr sz="850" dirty="0">
                 <a:solidFill>
                   <a:srgbClr val="BBBBBB"/>
                 </a:solidFill>
@@ -23919,12 +24023,33 @@
                 <a:spcPts val="0"/>
               </a:spcAft>
             </a:pPr>
-            <a:endParaRPr sz="850">
-              <a:solidFill>
-                <a:srgbClr val="BBBBBB"/>
-              </a:solidFill>
-              <a:latin typeface="Courier New"/>
-            </a:endParaRPr>
+            <a:r>
+              <a:rPr sz="850" dirty="0">
+                <a:solidFill>
+                  <a:srgbClr val="9CDCFE"/>
+                </a:solidFill>
+                <a:latin typeface="Courier New"/>
+              </a:rPr>
+              <a:t>  </a:t>
+            </a:r>
+            <a:r>
+              <a:rPr sz="850" dirty="0" err="1">
+                <a:solidFill>
+                  <a:srgbClr val="9CDCFE"/>
+                </a:solidFill>
+                <a:latin typeface="Courier New"/>
+              </a:rPr>
+              <a:t>private_key_file</a:t>
+            </a:r>
+            <a:r>
+              <a:rPr sz="850" dirty="0">
+                <a:solidFill>
+                  <a:srgbClr val="9CDCFE"/>
+                </a:solidFill>
+                <a:latin typeface="Courier New"/>
+              </a:rPr>
+              <a:t>: </a:t>
+            </a:r>
           </a:p>
           <a:p>
             <a:pPr>
@@ -23936,7 +24061,98 @@
               </a:spcAft>
             </a:pPr>
             <a:r>
-              <a:rPr sz="850">
+              <a:rPr sz="850" dirty="0">
+                <a:solidFill>
+                  <a:srgbClr val="BBBBBB"/>
+                </a:solidFill>
+                <a:latin typeface="Courier New"/>
+              </a:rPr>
+              <a:t>  Enter path to .p8 key file, or leave blank to use password: </a:t>
+            </a:r>
+          </a:p>
+          <a:p>
+            <a:pPr>
+              <a:spcBef>
+                <a:spcPts val="0"/>
+              </a:spcBef>
+              <a:spcAft>
+                <a:spcPts val="0"/>
+              </a:spcAft>
+            </a:pPr>
+            <a:r>
+              <a:rPr sz="850" dirty="0">
+                <a:solidFill>
+                  <a:srgbClr val="9CDCFE"/>
+                </a:solidFill>
+                <a:latin typeface="Courier New"/>
+              </a:rPr>
+              <a:t>  </a:t>
+            </a:r>
+            <a:r>
+              <a:rPr sz="850" dirty="0" err="1">
+                <a:solidFill>
+                  <a:srgbClr val="9CDCFE"/>
+                </a:solidFill>
+                <a:latin typeface="Courier New"/>
+              </a:rPr>
+              <a:t>private_key_passphrase</a:t>
+            </a:r>
+            <a:r>
+              <a:rPr sz="850" dirty="0">
+                <a:solidFill>
+                  <a:srgbClr val="9CDCFE"/>
+                </a:solidFill>
+                <a:latin typeface="Courier New"/>
+              </a:rPr>
+              <a:t>: </a:t>
+            </a:r>
+          </a:p>
+          <a:p>
+            <a:pPr>
+              <a:spcBef>
+                <a:spcPts val="0"/>
+              </a:spcBef>
+              <a:spcAft>
+                <a:spcPts val="0"/>
+              </a:spcAft>
+            </a:pPr>
+            <a:r>
+              <a:rPr sz="850" dirty="0">
+                <a:solidFill>
+                  <a:srgbClr val="BBBBBB"/>
+                </a:solidFill>
+                <a:latin typeface="Courier New"/>
+              </a:rPr>
+              <a:t>  Enter passphrase, or leave blank if key is unencrypted: </a:t>
+            </a:r>
+          </a:p>
+          <a:p>
+            <a:pPr>
+              <a:spcBef>
+                <a:spcPts val="0"/>
+              </a:spcBef>
+              <a:spcAft>
+                <a:spcPts val="0"/>
+              </a:spcAft>
+            </a:pPr>
+            <a:endParaRPr sz="850" dirty="0">
+              <a:solidFill>
+                <a:srgbClr val="BBBBBB"/>
+              </a:solidFill>
+              <a:latin typeface="Courier New"/>
+            </a:endParaRPr>
+          </a:p>
+          <a:p>
+            <a:pPr>
+              <a:spcBef>
+                <a:spcPts val="0"/>
+              </a:spcBef>
+              <a:spcAft>
+                <a:spcPts val="0"/>
+              </a:spcAft>
+            </a:pPr>
+            <a:r>
+              <a:rPr sz="850" dirty="0">
                 <a:solidFill>
                   <a:srgbClr val="4EC974"/>
                 </a:solidFill>
@@ -26789,6 +27005,15 @@
 </file>
 
 <file path=customXml/item1.xml><?xml version="1.0" encoding="utf-8"?>
+<?mso-contentType ?>
+<FormTemplates xmlns="http://schemas.microsoft.com/sharepoint/v3/contenttype/forms">
+  <Display>DocumentLibraryForm</Display>
+  <Edit>DocumentLibraryForm</Edit>
+  <New>DocumentLibraryForm</New>
+</FormTemplates>
+</file>
+
+<file path=customXml/item2.xml><?xml version="1.0" encoding="utf-8"?>
 <ct:contentTypeSchema xmlns:ct="http://schemas.microsoft.com/office/2006/metadata/contentType" xmlns:ma="http://schemas.microsoft.com/office/2006/metadata/properties/metaAttributes" ct:_="" ma:_="" ma:contentTypeName="Document" ma:contentTypeID="0x0101008F469B9DDCB7884E95DD88D1FAB455BB" ma:contentTypeVersion="4" ma:contentTypeDescription="Create a new document." ma:contentTypeScope="" ma:versionID="2af74787b6fa7b67583c56dc5776735d">
   <xsd:schema xmlns:xsd="http://www.w3.org/2001/XMLSchema" xmlns:xs="http://www.w3.org/2001/XMLSchema" xmlns:p="http://schemas.microsoft.com/office/2006/metadata/properties" xmlns:ns2="d7abb67f-8ba3-4629-af4a-9ad47f056db5" targetNamespace="http://schemas.microsoft.com/office/2006/metadata/properties" ma:root="true" ma:fieldsID="03e5ccd49f08cdc976c4df5b8baab980" ns2:_="">
     <xsd:import namespace="d7abb67f-8ba3-4629-af4a-9ad47f056db5"/>
@@ -26934,16 +27159,15 @@
 </ct:contentTypeSchema>
 </file>
 
-<file path=customXml/item2.xml><?xml version="1.0" encoding="utf-8"?>
-<?mso-contentType ?>
-<FormTemplates xmlns="http://schemas.microsoft.com/sharepoint/v3/contenttype/forms">
-  <Display>DocumentLibraryForm</Display>
-  <Edit>DocumentLibraryForm</Edit>
-  <New>DocumentLibraryForm</New>
-</FormTemplates>
+<file path=customXml/itemProps1.xml><?xml version="1.0" encoding="utf-8"?>
+<ds:datastoreItem xmlns:ds="http://schemas.openxmlformats.org/officeDocument/2006/customXml" ds:itemID="{0FFC13DC-9E91-480E-AA50-E69DFCF153D3}">
+  <ds:schemaRefs>
+    <ds:schemaRef ds:uri="http://schemas.microsoft.com/sharepoint/v3/contenttype/forms"/>
+  </ds:schemaRefs>
+</ds:datastoreItem>
 </file>
 
-<file path=customXml/itemProps1.xml><?xml version="1.0" encoding="utf-8"?>
+<file path=customXml/itemProps2.xml><?xml version="1.0" encoding="utf-8"?>
 <ds:datastoreItem xmlns:ds="http://schemas.openxmlformats.org/officeDocument/2006/customXml" ds:itemID="{5CA5433E-CDB9-440C-BB77-1799205ED86D}">
   <ds:schemaRefs>
     <ds:schemaRef ds:uri="d7abb67f-8ba3-4629-af4a-9ad47f056db5"/>
@@ -26961,14 +27185,6 @@
 </ds:datastoreItem>
 </file>
 
-<file path=customXml/itemProps2.xml><?xml version="1.0" encoding="utf-8"?>
-<ds:datastoreItem xmlns:ds="http://schemas.openxmlformats.org/officeDocument/2006/customXml" ds:itemID="{0FFC13DC-9E91-480E-AA50-E69DFCF153D3}">
-  <ds:schemaRefs>
-    <ds:schemaRef ds:uri="http://schemas.microsoft.com/sharepoint/v3/contenttype/forms"/>
-  </ds:schemaRefs>
-</ds:datastoreItem>
-</file>
-
 <file path=docMetadata/LabelInfo.xml><?xml version="1.0" encoding="utf-8"?>
 <clbl:labelList xmlns:clbl="http://schemas.microsoft.com/office/2020/mipLabelMetadata">
   <clbl:label id="{14c8150c-bc7e-4d77-82d5-2d0905f0cd74}" enabled="1" method="Standard" siteId="{2638f43e-f77d-4fc7-ab92-7b753b7876fd}" contentBits="0" removed="0"/>

</xml_diff>